<commit_message>
Update electrical diagram files
Replace Diagrama elétrico assets in docs/fluxogramas: updated PNG and PPTX files. These commits refresh the electrical diagram visuals and the source presentation.
</commit_message>
<xml_diff>
--- a/docs/fluxogramas/Diagrama elétrico.pptx
+++ b/docs/fluxogramas/Diagrama elétrico.pptx
@@ -105,6 +105,11 @@
       </a:defRPr>
     </a:lvl9pPr>
   </p:defaultTextStyle>
+  <p:extLst>
+    <p:ext uri="{EFAFB233-063F-42B5-8137-9DF3F51BA10A}">
+      <p15:sldGuideLst xmlns:p15="http://schemas.microsoft.com/office/powerpoint/2012/main"/>
+    </p:ext>
+  </p:extLst>
 </p:presentation>
 </file>
 
@@ -11462,6 +11467,41 @@
           </a:fontRef>
         </p:style>
       </p:cxnSp>
+      <p:sp>
+        <p:nvSpPr>
+          <p:cNvPr id="3" name="CaixaDeTexto 2">
+            <a:extLst>
+              <a:ext uri="{FF2B5EF4-FFF2-40B4-BE49-F238E27FC236}">
+                <a16:creationId xmlns:a16="http://schemas.microsoft.com/office/drawing/2014/main" id="{D4A206BD-170D-3024-E021-253DE3A45D81}"/>
+              </a:ext>
+            </a:extLst>
+          </p:cNvPr>
+          <p:cNvSpPr txBox="1"/>
+          <p:nvPr/>
+        </p:nvSpPr>
+        <p:spPr>
+          <a:xfrm>
+            <a:off x="9156181" y="2849150"/>
+            <a:ext cx="320922" cy="369332"/>
+          </a:xfrm>
+          <a:prstGeom prst="rect">
+            <a:avLst/>
+          </a:prstGeom>
+          <a:noFill/>
+        </p:spPr>
+        <p:txBody>
+          <a:bodyPr wrap="square" rtlCol="0">
+            <a:spAutoFit/>
+          </a:bodyPr>
+          <a:lstStyle/>
+          <a:p>
+            <a:r>
+              <a:rPr lang="pt-BR" dirty="0"/>
+              <a:t>C</a:t>
+            </a:r>
+          </a:p>
+        </p:txBody>
+      </p:sp>
     </p:spTree>
     <p:extLst>
       <p:ext uri="{BB962C8B-B14F-4D97-AF65-F5344CB8AC3E}">

</xml_diff>

<commit_message>
docs(diagrama): rótulo IRF520_C da esteira C e Figura 2 do artigo atualizada
Co-Authored-By: Claude Opus 5.5 <noreply@anthropic.com>
</commit_message>
<xml_diff>
--- a/docs/fluxogramas/Diagrama elétrico.pptx
+++ b/docs/fluxogramas/Diagrama elétrico.pptx
@@ -260,7 +260,7 @@
           <a:p>
             <a:fld id="{1F0D6F6C-3F5A-4DD0-A5B9-478E596853C1}" type="datetimeFigureOut">
               <a:rPr lang="pt-BR" smtClean="0"/>
-              <a:t>23/09/2026</a:t>
+              <a:t>08/10/2026</a:t>
             </a:fld>
             <a:endParaRPr lang="pt-BR"/>
           </a:p>
@@ -458,7 +458,7 @@
           <a:p>
             <a:fld id="{1F0D6F6C-3F5A-4DD0-A5B9-478E596853C1}" type="datetimeFigureOut">
               <a:rPr lang="pt-BR" smtClean="0"/>
-              <a:t>23/09/2026</a:t>
+              <a:t>08/10/2026</a:t>
             </a:fld>
             <a:endParaRPr lang="pt-BR"/>
           </a:p>
@@ -666,7 +666,7 @@
           <a:p>
             <a:fld id="{1F0D6F6C-3F5A-4DD0-A5B9-478E596853C1}" type="datetimeFigureOut">
               <a:rPr lang="pt-BR" smtClean="0"/>
-              <a:t>23/09/2026</a:t>
+              <a:t>08/10/2026</a:t>
             </a:fld>
             <a:endParaRPr lang="pt-BR"/>
           </a:p>
@@ -864,7 +864,7 @@
           <a:p>
             <a:fld id="{1F0D6F6C-3F5A-4DD0-A5B9-478E596853C1}" type="datetimeFigureOut">
               <a:rPr lang="pt-BR" smtClean="0"/>
-              <a:t>23/09/2026</a:t>
+              <a:t>08/10/2026</a:t>
             </a:fld>
             <a:endParaRPr lang="pt-BR"/>
           </a:p>
@@ -1139,7 +1139,7 @@
           <a:p>
             <a:fld id="{1F0D6F6C-3F5A-4DD0-A5B9-478E596853C1}" type="datetimeFigureOut">
               <a:rPr lang="pt-BR" smtClean="0"/>
-              <a:t>23/09/2026</a:t>
+              <a:t>08/10/2026</a:t>
             </a:fld>
             <a:endParaRPr lang="pt-BR"/>
           </a:p>
@@ -1404,7 +1404,7 @@
           <a:p>
             <a:fld id="{1F0D6F6C-3F5A-4DD0-A5B9-478E596853C1}" type="datetimeFigureOut">
               <a:rPr lang="pt-BR" smtClean="0"/>
-              <a:t>23/09/2026</a:t>
+              <a:t>08/10/2026</a:t>
             </a:fld>
             <a:endParaRPr lang="pt-BR"/>
           </a:p>
@@ -1816,7 +1816,7 @@
           <a:p>
             <a:fld id="{1F0D6F6C-3F5A-4DD0-A5B9-478E596853C1}" type="datetimeFigureOut">
               <a:rPr lang="pt-BR" smtClean="0"/>
-              <a:t>23/09/2026</a:t>
+              <a:t>08/10/2026</a:t>
             </a:fld>
             <a:endParaRPr lang="pt-BR"/>
           </a:p>
@@ -1957,7 +1957,7 @@
           <a:p>
             <a:fld id="{1F0D6F6C-3F5A-4DD0-A5B9-478E596853C1}" type="datetimeFigureOut">
               <a:rPr lang="pt-BR" smtClean="0"/>
-              <a:t>23/09/2026</a:t>
+              <a:t>08/10/2026</a:t>
             </a:fld>
             <a:endParaRPr lang="pt-BR"/>
           </a:p>
@@ -2070,7 +2070,7 @@
           <a:p>
             <a:fld id="{1F0D6F6C-3F5A-4DD0-A5B9-478E596853C1}" type="datetimeFigureOut">
               <a:rPr lang="pt-BR" smtClean="0"/>
-              <a:t>23/09/2026</a:t>
+              <a:t>08/10/2026</a:t>
             </a:fld>
             <a:endParaRPr lang="pt-BR"/>
           </a:p>
@@ -2381,7 +2381,7 @@
           <a:p>
             <a:fld id="{1F0D6F6C-3F5A-4DD0-A5B9-478E596853C1}" type="datetimeFigureOut">
               <a:rPr lang="pt-BR" smtClean="0"/>
-              <a:t>23/09/2026</a:t>
+              <a:t>08/10/2026</a:t>
             </a:fld>
             <a:endParaRPr lang="pt-BR"/>
           </a:p>
@@ -2669,7 +2669,7 @@
           <a:p>
             <a:fld id="{1F0D6F6C-3F5A-4DD0-A5B9-478E596853C1}" type="datetimeFigureOut">
               <a:rPr lang="pt-BR" smtClean="0"/>
-              <a:t>23/09/2026</a:t>
+              <a:t>08/10/2026</a:t>
             </a:fld>
             <a:endParaRPr lang="pt-BR"/>
           </a:p>
@@ -2910,7 +2910,7 @@
           <a:p>
             <a:fld id="{1F0D6F6C-3F5A-4DD0-A5B9-478E596853C1}" type="datetimeFigureOut">
               <a:rPr lang="pt-BR" smtClean="0"/>
-              <a:t>23/09/2026</a:t>
+              <a:t>08/10/2026</a:t>
             </a:fld>
             <a:endParaRPr lang="pt-BR"/>
           </a:p>
@@ -6039,8 +6039,8 @@
               </p:nvSpPr>
               <p:spPr>
                 <a:xfrm>
-                  <a:off x="3704305" y="1713665"/>
-                  <a:ext cx="1117614" cy="369332"/>
+                  <a:off x="3704304" y="1713665"/>
+                  <a:ext cx="1187003" cy="369332"/>
                 </a:xfrm>
                 <a:prstGeom prst="rect">
                   <a:avLst/>
@@ -8197,9 +8197,9 @@
         <p:grpSpPr>
           <a:xfrm>
             <a:off x="3504834" y="10729861"/>
-            <a:ext cx="1267400" cy="1763679"/>
+            <a:ext cx="1274760" cy="1763679"/>
             <a:chOff x="3656404" y="2328458"/>
-            <a:chExt cx="1267400" cy="1763679"/>
+            <a:chExt cx="1274760" cy="1763679"/>
           </a:xfrm>
         </p:grpSpPr>
         <p:grpSp>
@@ -8217,9 +8217,9 @@
           <p:grpSpPr>
             <a:xfrm>
               <a:off x="3656404" y="2328458"/>
-              <a:ext cx="1267400" cy="1763679"/>
+              <a:ext cx="1274760" cy="1763679"/>
               <a:chOff x="3644833" y="1713665"/>
-              <a:chExt cx="1267400" cy="1763679"/>
+              <a:chExt cx="1274760" cy="1763679"/>
             </a:xfrm>
           </p:grpSpPr>
           <p:grpSp>
@@ -8237,9 +8237,9 @@
             <p:grpSpPr>
               <a:xfrm>
                 <a:off x="3644833" y="1713665"/>
-                <a:ext cx="1267400" cy="1763679"/>
+                <a:ext cx="1274760" cy="1763679"/>
                 <a:chOff x="3644833" y="1713665"/>
-                <a:chExt cx="1267400" cy="1763679"/>
+                <a:chExt cx="1274760" cy="1763679"/>
               </a:xfrm>
             </p:grpSpPr>
             <p:sp>
@@ -8256,8 +8256,8 @@
               </p:nvSpPr>
               <p:spPr>
                 <a:xfrm>
-                  <a:off x="3704305" y="1713665"/>
-                  <a:ext cx="1117614" cy="369332"/>
+                  <a:off x="3704304" y="1713665"/>
+                  <a:ext cx="1215289" cy="369332"/>
                 </a:xfrm>
                 <a:prstGeom prst="rect">
                   <a:avLst/>
@@ -8272,7 +8272,7 @@
                 <a:p>
                   <a:r>
                     <a:rPr lang="pt-BR" dirty="0"/>
-                    <a:t>IRF520_B</a:t>
+                    <a:t>IRF520_C</a:t>
                   </a:r>
                 </a:p>
               </p:txBody>

</xml_diff>